<commit_message>
Thêm ví, phí tham gia
</commit_message>
<xml_diff>
--- a/docs/110122127-TruongNguyenToNguyen-Báo cáo-Khóa luận TN.pptx
+++ b/docs/110122127-TruongNguyenToNguyen-Báo cáo-Khóa luận TN.pptx
@@ -5,7 +5,7 @@
     <p:sldMasterId id="2147483648" r:id="rId1"/>
   </p:sldMasterIdLst>
   <p:notesMasterIdLst>
-    <p:notesMasterId r:id="rId18"/>
+    <p:notesMasterId r:id="rId17"/>
   </p:notesMasterIdLst>
   <p:sldIdLst>
     <p:sldId id="256" r:id="rId2"/>
@@ -17,13 +17,12 @@
     <p:sldId id="262" r:id="rId8"/>
     <p:sldId id="264" r:id="rId9"/>
     <p:sldId id="261" r:id="rId10"/>
-    <p:sldId id="270" r:id="rId11"/>
-    <p:sldId id="271" r:id="rId12"/>
-    <p:sldId id="272" r:id="rId13"/>
-    <p:sldId id="274" r:id="rId14"/>
-    <p:sldId id="275" r:id="rId15"/>
-    <p:sldId id="265" r:id="rId16"/>
-    <p:sldId id="269" r:id="rId17"/>
+    <p:sldId id="271" r:id="rId11"/>
+    <p:sldId id="272" r:id="rId12"/>
+    <p:sldId id="274" r:id="rId13"/>
+    <p:sldId id="275" r:id="rId14"/>
+    <p:sldId id="265" r:id="rId15"/>
+    <p:sldId id="269" r:id="rId16"/>
   </p:sldIdLst>
   <p:sldSz cx="9144000" cy="5143500" type="screen16x9"/>
   <p:notesSz cx="6858000" cy="9144000"/>
@@ -136,7 +135,6 @@
             <p14:sldId id="262"/>
             <p14:sldId id="264"/>
             <p14:sldId id="261"/>
-            <p14:sldId id="270"/>
             <p14:sldId id="271"/>
             <p14:sldId id="272"/>
             <p14:sldId id="274"/>
@@ -236,7 +234,7 @@
           <a:p>
             <a:fld id="{D48BCE06-DC01-4404-BB88-82118F689A3E}" type="datetimeFigureOut">
               <a:rPr lang="vi-VN" smtClean="0"/>
-              <a:t>06/07/2026</a:t>
+              <a:t>22/07/2026</a:t>
             </a:fld>
             <a:endParaRPr lang="vi-VN"/>
           </a:p>
@@ -569,7 +567,7 @@
           <a:p>
             <a:fld id="{0C184B33-0608-452E-AA1F-2691FC844A4A}" type="slidenum">
               <a:rPr lang="vi-VN" smtClean="0"/>
-              <a:t>11</a:t>
+              <a:t>10</a:t>
             </a:fld>
             <a:endParaRPr lang="vi-VN"/>
           </a:p>
@@ -653,7 +651,7 @@
           <a:p>
             <a:fld id="{0C184B33-0608-452E-AA1F-2691FC844A4A}" type="slidenum">
               <a:rPr lang="vi-VN" smtClean="0"/>
-              <a:t>12</a:t>
+              <a:t>11</a:t>
             </a:fld>
             <a:endParaRPr lang="vi-VN"/>
           </a:p>
@@ -1781,6 +1779,60 @@
           <a:chExt cx="0" cy="0"/>
         </a:xfrm>
       </p:grpSpPr>
+      <p:sp>
+        <p:nvSpPr>
+          <p:cNvPr id="2" name="Flowchart: Connector 1">
+            <a:extLst>
+              <a:ext uri="{FF2B5EF4-FFF2-40B4-BE49-F238E27FC236}">
+                <a16:creationId xmlns:a16="http://schemas.microsoft.com/office/drawing/2014/main" id="{0F78E1EA-18F5-B18F-0E1B-690C79193CA0}"/>
+              </a:ext>
+            </a:extLst>
+          </p:cNvPr>
+          <p:cNvSpPr/>
+          <p:nvPr/>
+        </p:nvSpPr>
+        <p:spPr>
+          <a:xfrm>
+            <a:off x="104140" y="81280"/>
+            <a:ext cx="953473" cy="962409"/>
+          </a:xfrm>
+          <a:prstGeom prst="flowChartConnector">
+            <a:avLst/>
+          </a:prstGeom>
+          <a:solidFill>
+            <a:schemeClr val="tx1"/>
+          </a:solidFill>
+          <a:ln>
+            <a:solidFill>
+              <a:schemeClr val="tx1"/>
+            </a:solidFill>
+          </a:ln>
+        </p:spPr>
+        <p:style>
+          <a:lnRef idx="2">
+            <a:schemeClr val="accent1">
+              <a:shade val="15000"/>
+            </a:schemeClr>
+          </a:lnRef>
+          <a:fillRef idx="1">
+            <a:schemeClr val="accent1"/>
+          </a:fillRef>
+          <a:effectRef idx="0">
+            <a:schemeClr val="accent1"/>
+          </a:effectRef>
+          <a:fontRef idx="minor">
+            <a:schemeClr val="lt1"/>
+          </a:fontRef>
+        </p:style>
+        <p:txBody>
+          <a:bodyPr rtlCol="0" anchor="ctr"/>
+          <a:lstStyle/>
+          <a:p>
+            <a:pPr algn="ctr"/>
+            <a:endParaRPr lang="vi-VN"/>
+          </a:p>
+        </p:txBody>
+      </p:sp>
       <p:grpSp>
         <p:nvGrpSpPr>
           <p:cNvPr id="8" name="Google Shape;154;p32"/>
@@ -18417,10 +18469,10 @@
       </p:sp>
       <p:pic>
         <p:nvPicPr>
-          <p:cNvPr id="4" name="Picture 3">
+          <p:cNvPr id="7" name="Picture 6">
             <a:extLst>
               <a:ext uri="{FF2B5EF4-FFF2-40B4-BE49-F238E27FC236}">
-                <a16:creationId xmlns:a16="http://schemas.microsoft.com/office/drawing/2014/main" id="{E8AB30A2-8D32-0258-A80C-69742DB430D2}"/>
+                <a16:creationId xmlns:a16="http://schemas.microsoft.com/office/drawing/2014/main" id="{D5AC3439-FD53-87B1-3987-8A5777E4B7CF}"/>
               </a:ext>
             </a:extLst>
           </p:cNvPr>
@@ -18443,8 +18495,8 @@
         </p:blipFill>
         <p:spPr>
           <a:xfrm>
-            <a:off x="120866" y="174455"/>
-            <a:ext cx="839310" cy="839310"/>
+            <a:off x="78312" y="59920"/>
+            <a:ext cx="1005127" cy="1005127"/>
           </a:xfrm>
           <a:prstGeom prst="rect">
             <a:avLst/>
@@ -18533,69 +18585,190 @@
                 </a:solidFill>
                 <a:latin typeface="Orbitron"/>
               </a:rPr>
-              <a:t>Cơ sở dữ liệu (ERD)</a:t>
+              <a:t>Sơ đồ luồng Đặt giá</a:t>
+            </a:r>
+          </a:p>
+        </p:txBody>
+      </p:sp>
+      <p:sp>
+        <p:nvSpPr>
+          <p:cNvPr id="302" name="lbl_bf"/>
+          <p:cNvSpPr/>
+          <p:nvPr/>
+        </p:nvSpPr>
+        <p:spPr>
+          <a:xfrm>
+            <a:off x="300116" y="4655000"/>
+            <a:ext cx="3800000" cy="280000"/>
+          </a:xfrm>
+          <a:prstGeom prst="rect">
+            <a:avLst/>
+          </a:prstGeom>
+          <a:noFill/>
+          <a:ln w="0">
+            <a:noFill/>
+          </a:ln>
+        </p:spPr>
+        <p:style>
+          <a:lnRef idx="0">
+            <a:scrgbClr r="0" g="0" b="0"/>
+          </a:lnRef>
+          <a:fillRef idx="0">
+            <a:scrgbClr r="0" g="0" b="0"/>
+          </a:fillRef>
+          <a:effectRef idx="0">
+            <a:scrgbClr r="0" g="0" b="0"/>
+          </a:effectRef>
+          <a:fontRef idx="minor"/>
+        </p:style>
+        <p:txBody>
+          <a:bodyPr anchor="ctr">
+            <a:normAutofit/>
+          </a:bodyPr>
+          <a:lstStyle/>
+          <a:p>
+            <a:pPr algn="ctr"/>
+            <a:r>
+              <a:rPr lang="en-US" sz="1100" b="1">
+                <a:solidFill>
+                  <a:srgbClr val="92F7FF"/>
+                </a:solidFill>
+                <a:latin typeface="Archivo Light"/>
+              </a:rPr>
+              <a:t>S</a:t>
+            </a:r>
+            <a:r>
+              <a:rPr lang="vi-VN" sz="1100" b="1">
+                <a:solidFill>
+                  <a:srgbClr val="92F7FF"/>
+                </a:solidFill>
+                <a:latin typeface="Archivo Light"/>
+              </a:rPr>
+              <a:t>ơ đồ hoạt động</a:t>
+            </a:r>
+          </a:p>
+        </p:txBody>
+      </p:sp>
+      <p:sp>
+        <p:nvSpPr>
+          <p:cNvPr id="304" name="lbl_bs"/>
+          <p:cNvSpPr/>
+          <p:nvPr/>
+        </p:nvSpPr>
+        <p:spPr>
+          <a:xfrm>
+            <a:off x="3763522" y="4655000"/>
+            <a:ext cx="4600000" cy="280000"/>
+          </a:xfrm>
+          <a:prstGeom prst="rect">
+            <a:avLst/>
+          </a:prstGeom>
+          <a:noFill/>
+          <a:ln w="0">
+            <a:noFill/>
+          </a:ln>
+        </p:spPr>
+        <p:style>
+          <a:lnRef idx="0">
+            <a:scrgbClr r="0" g="0" b="0"/>
+          </a:lnRef>
+          <a:fillRef idx="0">
+            <a:scrgbClr r="0" g="0" b="0"/>
+          </a:fillRef>
+          <a:effectRef idx="0">
+            <a:scrgbClr r="0" g="0" b="0"/>
+          </a:effectRef>
+          <a:fontRef idx="minor"/>
+        </p:style>
+        <p:txBody>
+          <a:bodyPr anchor="ctr">
+            <a:normAutofit/>
+          </a:bodyPr>
+          <a:lstStyle/>
+          <a:p>
+            <a:pPr algn="ctr"/>
+            <a:r>
+              <a:rPr lang="vi-VN" sz="1100" b="1">
+                <a:solidFill>
+                  <a:srgbClr val="92F7FF"/>
+                </a:solidFill>
+                <a:latin typeface="Archivo Light"/>
+              </a:rPr>
+              <a:t>Sơ đồ tuần tự</a:t>
             </a:r>
           </a:p>
         </p:txBody>
       </p:sp>
       <p:pic>
         <p:nvPicPr>
-          <p:cNvPr id="2050" name="Picture 2">
+          <p:cNvPr id="3" name="Picture 2">
             <a:extLst>
               <a:ext uri="{FF2B5EF4-FFF2-40B4-BE49-F238E27FC236}">
-                <a16:creationId xmlns:a16="http://schemas.microsoft.com/office/drawing/2014/main" id="{B17C0491-DA17-359B-17AE-E5211FC4924F}"/>
+                <a16:creationId xmlns:a16="http://schemas.microsoft.com/office/drawing/2014/main" id="{544330EF-01EE-D553-FDDC-08DD984F3D9C}"/>
               </a:ext>
             </a:extLst>
           </p:cNvPr>
           <p:cNvPicPr>
-            <a:picLocks noChangeAspect="1" noChangeArrowheads="1"/>
+            <a:picLocks noChangeAspect="1"/>
           </p:cNvPicPr>
           <p:nvPr/>
         </p:nvPicPr>
         <p:blipFill>
-          <a:blip r:embed="rId2">
+          <a:blip r:embed="rId3" cstate="print">
             <a:extLst>
               <a:ext uri="{28A0092B-C50C-407E-A947-70E740481C1C}">
                 <a14:useLocalDpi xmlns:a14="http://schemas.microsoft.com/office/drawing/2010/main" val="0"/>
               </a:ext>
             </a:extLst>
           </a:blip>
-          <a:srcRect/>
           <a:stretch>
             <a:fillRect/>
           </a:stretch>
         </p:blipFill>
-        <p:spPr bwMode="auto">
+        <p:spPr>
           <a:xfrm>
-            <a:off x="787079" y="899895"/>
-            <a:ext cx="7592992" cy="4152773"/>
+            <a:off x="1326629" y="978986"/>
+            <a:ext cx="1925468" cy="3654083"/>
           </a:xfrm>
           <a:prstGeom prst="rect">
             <a:avLst/>
           </a:prstGeom>
-          <a:noFill/>
-          <a:ln>
-            <a:noFill/>
-          </a:ln>
-          <a:extLst>
-            <a:ext uri="{909E8E84-426E-40DD-AFC4-6F175D3DCCD1}">
-              <a14:hiddenFill xmlns:a14="http://schemas.microsoft.com/office/drawing/2010/main">
-                <a:solidFill>
-                  <a:srgbClr val="FFFFFF"/>
-                </a:solidFill>
-              </a14:hiddenFill>
-            </a:ext>
-            <a:ext uri="{91240B29-F687-4F45-9708-019B960494DF}">
-              <a14:hiddenLine xmlns:a14="http://schemas.microsoft.com/office/drawing/2010/main" w="9525">
-                <a:solidFill>
-                  <a:srgbClr val="000000"/>
-                </a:solidFill>
-                <a:miter lim="800000"/>
-                <a:headEnd/>
-                <a:tailEnd/>
-              </a14:hiddenLine>
-            </a:ext>
-          </a:extLst>
+        </p:spPr>
+      </p:pic>
+      <p:pic>
+        <p:nvPicPr>
+          <p:cNvPr id="5" name="Picture 4">
+            <a:extLst>
+              <a:ext uri="{FF2B5EF4-FFF2-40B4-BE49-F238E27FC236}">
+                <a16:creationId xmlns:a16="http://schemas.microsoft.com/office/drawing/2014/main" id="{E14C55B8-12A2-25DC-59D0-A34DDAAAB994}"/>
+              </a:ext>
+            </a:extLst>
+          </p:cNvPr>
+          <p:cNvPicPr>
+            <a:picLocks noChangeAspect="1"/>
+          </p:cNvPicPr>
+          <p:nvPr/>
+        </p:nvPicPr>
+        <p:blipFill>
+          <a:blip r:embed="rId4" cstate="print">
+            <a:extLst>
+              <a:ext uri="{28A0092B-C50C-407E-A947-70E740481C1C}">
+                <a14:useLocalDpi xmlns:a14="http://schemas.microsoft.com/office/drawing/2010/main" val="0"/>
+              </a:ext>
+            </a:extLst>
+          </a:blip>
+          <a:stretch>
+            <a:fillRect/>
+          </a:stretch>
+        </p:blipFill>
+        <p:spPr>
+          <a:xfrm>
+            <a:off x="4309673" y="1000917"/>
+            <a:ext cx="3507698" cy="3654083"/>
+          </a:xfrm>
+          <a:prstGeom prst="rect">
+            <a:avLst/>
+          </a:prstGeom>
         </p:spPr>
       </p:pic>
     </p:spTree>
@@ -18680,7 +18853,7 @@
                 </a:solidFill>
                 <a:latin typeface="Orbitron"/>
               </a:rPr>
-              <a:t>Sơ đồ luồng Đặt giá</a:t>
+              <a:t>Sơ đồ luồng Mua ngay</a:t>
             </a:r>
           </a:p>
         </p:txBody>
@@ -18693,7 +18866,7 @@
         </p:nvSpPr>
         <p:spPr>
           <a:xfrm>
-            <a:off x="-374441" y="4633069"/>
+            <a:off x="263331" y="4687170"/>
             <a:ext cx="3800000" cy="280000"/>
           </a:xfrm>
           <a:prstGeom prst="rect">
@@ -18724,22 +18897,13 @@
           <a:p>
             <a:pPr algn="ctr"/>
             <a:r>
-              <a:rPr lang="en-US" sz="1100" b="1">
+              <a:rPr lang="vi-VN" sz="1100" b="1">
                 <a:solidFill>
                   <a:srgbClr val="92F7FF"/>
                 </a:solidFill>
                 <a:latin typeface="Archivo Light"/>
               </a:rPr>
-              <a:t>S</a:t>
-            </a:r>
-            <a:r>
-              <a:rPr lang="vi-VN" sz="1100" b="1">
-                <a:solidFill>
-                  <a:srgbClr val="92F7FF"/>
-                </a:solidFill>
-                <a:latin typeface="Archivo Light"/>
-              </a:rPr>
-              <a:t>ơ đồ hoạt động</a:t>
+              <a:t>Sơ đồ hoạt động</a:t>
             </a:r>
           </a:p>
         </p:txBody>
@@ -18752,7 +18916,7 @@
         </p:nvSpPr>
         <p:spPr>
           <a:xfrm>
-            <a:off x="3596124" y="4655000"/>
+            <a:off x="4162635" y="4687170"/>
             <a:ext cx="4600000" cy="280000"/>
           </a:xfrm>
           <a:prstGeom prst="rect">
@@ -18796,122 +18960,74 @@
       </p:sp>
       <p:pic>
         <p:nvPicPr>
-          <p:cNvPr id="3074" name="Picture 2">
+          <p:cNvPr id="3" name="Picture 2">
             <a:extLst>
               <a:ext uri="{FF2B5EF4-FFF2-40B4-BE49-F238E27FC236}">
-                <a16:creationId xmlns:a16="http://schemas.microsoft.com/office/drawing/2014/main" id="{EEC18215-F2D9-7316-BDA9-09EC109F4C01}"/>
+                <a16:creationId xmlns:a16="http://schemas.microsoft.com/office/drawing/2014/main" id="{FE3F3100-72FF-F902-03E7-0AE28FB35020}"/>
               </a:ext>
             </a:extLst>
           </p:cNvPr>
           <p:cNvPicPr>
-            <a:picLocks noChangeAspect="1" noChangeArrowheads="1"/>
+            <a:picLocks noChangeAspect="1"/>
           </p:cNvPicPr>
           <p:nvPr/>
         </p:nvPicPr>
         <p:blipFill>
-          <a:blip r:embed="rId3">
+          <a:blip r:embed="rId3" cstate="print">
             <a:extLst>
               <a:ext uri="{28A0092B-C50C-407E-A947-70E740481C1C}">
                 <a14:useLocalDpi xmlns:a14="http://schemas.microsoft.com/office/drawing/2010/main" val="0"/>
               </a:ext>
             </a:extLst>
           </a:blip>
-          <a:srcRect/>
           <a:stretch>
             <a:fillRect/>
           </a:stretch>
         </p:blipFill>
-        <p:spPr bwMode="auto">
+        <p:spPr>
           <a:xfrm>
-            <a:off x="585710" y="853199"/>
-            <a:ext cx="1879698" cy="3776801"/>
+            <a:off x="4463331" y="1080327"/>
+            <a:ext cx="3800000" cy="3606843"/>
           </a:xfrm>
           <a:prstGeom prst="rect">
             <a:avLst/>
           </a:prstGeom>
-          <a:noFill/>
-          <a:ln>
-            <a:noFill/>
-          </a:ln>
-          <a:extLst>
-            <a:ext uri="{909E8E84-426E-40DD-AFC4-6F175D3DCCD1}">
-              <a14:hiddenFill xmlns:a14="http://schemas.microsoft.com/office/drawing/2010/main">
-                <a:solidFill>
-                  <a:srgbClr val="FFFFFF"/>
-                </a:solidFill>
-              </a14:hiddenFill>
-            </a:ext>
-            <a:ext uri="{91240B29-F687-4F45-9708-019B960494DF}">
-              <a14:hiddenLine xmlns:a14="http://schemas.microsoft.com/office/drawing/2010/main" w="9525">
-                <a:solidFill>
-                  <a:srgbClr val="000000"/>
-                </a:solidFill>
-                <a:miter lim="800000"/>
-                <a:headEnd/>
-                <a:tailEnd/>
-              </a14:hiddenLine>
-            </a:ext>
-          </a:extLst>
         </p:spPr>
       </p:pic>
       <p:pic>
         <p:nvPicPr>
-          <p:cNvPr id="3075" name="Picture 3">
+          <p:cNvPr id="5" name="Picture 4">
             <a:extLst>
               <a:ext uri="{FF2B5EF4-FFF2-40B4-BE49-F238E27FC236}">
-                <a16:creationId xmlns:a16="http://schemas.microsoft.com/office/drawing/2014/main" id="{F1DCCE3F-74D2-F220-C39D-E64F4CFE7970}"/>
+                <a16:creationId xmlns:a16="http://schemas.microsoft.com/office/drawing/2014/main" id="{EFBCAE3C-AC00-66A1-501E-8F83245782EC}"/>
               </a:ext>
             </a:extLst>
           </p:cNvPr>
           <p:cNvPicPr>
-            <a:picLocks noChangeAspect="1" noChangeArrowheads="1"/>
+            <a:picLocks noChangeAspect="1"/>
           </p:cNvPicPr>
           <p:nvPr/>
         </p:nvPicPr>
         <p:blipFill>
-          <a:blip r:embed="rId4">
+          <a:blip r:embed="rId4" cstate="print">
             <a:extLst>
               <a:ext uri="{28A0092B-C50C-407E-A947-70E740481C1C}">
                 <a14:useLocalDpi xmlns:a14="http://schemas.microsoft.com/office/drawing/2010/main" val="0"/>
               </a:ext>
             </a:extLst>
           </a:blip>
-          <a:srcRect/>
           <a:stretch>
             <a:fillRect/>
           </a:stretch>
         </p:blipFill>
-        <p:spPr bwMode="auto">
+        <p:spPr>
           <a:xfrm>
-            <a:off x="3177200" y="1489417"/>
-            <a:ext cx="5437848" cy="3165583"/>
+            <a:off x="762635" y="765368"/>
+            <a:ext cx="2900696" cy="3921802"/>
           </a:xfrm>
           <a:prstGeom prst="rect">
             <a:avLst/>
           </a:prstGeom>
-          <a:noFill/>
-          <a:ln>
-            <a:noFill/>
-          </a:ln>
-          <a:extLst>
-            <a:ext uri="{909E8E84-426E-40DD-AFC4-6F175D3DCCD1}">
-              <a14:hiddenFill xmlns:a14="http://schemas.microsoft.com/office/drawing/2010/main">
-                <a:solidFill>
-                  <a:srgbClr val="FFFFFF"/>
-                </a:solidFill>
-              </a14:hiddenFill>
-            </a:ext>
-            <a:ext uri="{91240B29-F687-4F45-9708-019B960494DF}">
-              <a14:hiddenLine xmlns:a14="http://schemas.microsoft.com/office/drawing/2010/main" w="9525">
-                <a:solidFill>
-                  <a:srgbClr val="000000"/>
-                </a:solidFill>
-                <a:miter lim="800000"/>
-                <a:headEnd/>
-                <a:tailEnd/>
-              </a14:hiddenLine>
-            </a:ext>
-          </a:extLst>
         </p:spPr>
       </p:pic>
     </p:spTree>
@@ -18935,313 +19051,6 @@
 </file>
 
 <file path=ppt/slides/slide12.xml><?xml version="1.0" encoding="utf-8"?>
-<p:sld xmlns:a="http://schemas.openxmlformats.org/drawingml/2006/main" xmlns:r="http://schemas.openxmlformats.org/officeDocument/2006/relationships" xmlns:p="http://schemas.openxmlformats.org/presentationml/2006/main">
-  <p:cSld>
-    <p:spTree>
-      <p:nvGrpSpPr>
-        <p:cNvPr id="1" name=""/>
-        <p:cNvGrpSpPr/>
-        <p:nvPr/>
-      </p:nvGrpSpPr>
-      <p:grpSpPr>
-        <a:xfrm>
-          <a:off x="0" y="0"/>
-          <a:ext cx="0" cy="0"/>
-          <a:chOff x="0" y="0"/>
-          <a:chExt cx="0" cy="0"/>
-        </a:xfrm>
-      </p:grpSpPr>
-      <p:sp>
-        <p:nvSpPr>
-          <p:cNvPr id="300" name="title"/>
-          <p:cNvSpPr/>
-          <p:nvPr/>
-        </p:nvSpPr>
-        <p:spPr>
-          <a:xfrm>
-            <a:off x="457200" y="400000"/>
-            <a:ext cx="8610840" cy="480000"/>
-          </a:xfrm>
-          <a:prstGeom prst="rect">
-            <a:avLst/>
-          </a:prstGeom>
-          <a:noFill/>
-          <a:ln w="0">
-            <a:noFill/>
-          </a:ln>
-        </p:spPr>
-        <p:style>
-          <a:lnRef idx="0">
-            <a:scrgbClr r="0" g="0" b="0"/>
-          </a:lnRef>
-          <a:fillRef idx="0">
-            <a:scrgbClr r="0" g="0" b="0"/>
-          </a:fillRef>
-          <a:effectRef idx="0">
-            <a:scrgbClr r="0" g="0" b="0"/>
-          </a:effectRef>
-          <a:fontRef idx="minor"/>
-        </p:style>
-        <p:txBody>
-          <a:bodyPr anchor="ctr">
-            <a:normAutofit/>
-          </a:bodyPr>
-          <a:lstStyle/>
-          <a:p>
-            <a:pPr algn="ctr"/>
-            <a:r>
-              <a:rPr lang="vi-VN" sz="2400" b="0">
-                <a:solidFill>
-                  <a:srgbClr val="92F7FF"/>
-                </a:solidFill>
-                <a:latin typeface="Orbitron"/>
-              </a:rPr>
-              <a:t>Sơ đồ luồng Mua ngay</a:t>
-            </a:r>
-          </a:p>
-        </p:txBody>
-      </p:sp>
-      <p:sp>
-        <p:nvSpPr>
-          <p:cNvPr id="302" name="lbl_bf"/>
-          <p:cNvSpPr/>
-          <p:nvPr/>
-        </p:nvSpPr>
-        <p:spPr>
-          <a:xfrm>
-            <a:off x="6974" y="4687170"/>
-            <a:ext cx="3800000" cy="280000"/>
-          </a:xfrm>
-          <a:prstGeom prst="rect">
-            <a:avLst/>
-          </a:prstGeom>
-          <a:noFill/>
-          <a:ln w="0">
-            <a:noFill/>
-          </a:ln>
-        </p:spPr>
-        <p:style>
-          <a:lnRef idx="0">
-            <a:scrgbClr r="0" g="0" b="0"/>
-          </a:lnRef>
-          <a:fillRef idx="0">
-            <a:scrgbClr r="0" g="0" b="0"/>
-          </a:fillRef>
-          <a:effectRef idx="0">
-            <a:scrgbClr r="0" g="0" b="0"/>
-          </a:effectRef>
-          <a:fontRef idx="minor"/>
-        </p:style>
-        <p:txBody>
-          <a:bodyPr anchor="ctr">
-            <a:normAutofit/>
-          </a:bodyPr>
-          <a:lstStyle/>
-          <a:p>
-            <a:pPr algn="ctr"/>
-            <a:r>
-              <a:rPr lang="vi-VN" sz="1100" b="1">
-                <a:solidFill>
-                  <a:srgbClr val="92F7FF"/>
-                </a:solidFill>
-                <a:latin typeface="Archivo Light"/>
-              </a:rPr>
-              <a:t>Sơ đồ hoạt động</a:t>
-            </a:r>
-          </a:p>
-        </p:txBody>
-      </p:sp>
-      <p:sp>
-        <p:nvSpPr>
-          <p:cNvPr id="304" name="lbl_bs"/>
-          <p:cNvSpPr/>
-          <p:nvPr/>
-        </p:nvSpPr>
-        <p:spPr>
-          <a:xfrm>
-            <a:off x="3936323" y="4687170"/>
-            <a:ext cx="4600000" cy="280000"/>
-          </a:xfrm>
-          <a:prstGeom prst="rect">
-            <a:avLst/>
-          </a:prstGeom>
-          <a:noFill/>
-          <a:ln w="0">
-            <a:noFill/>
-          </a:ln>
-        </p:spPr>
-        <p:style>
-          <a:lnRef idx="0">
-            <a:scrgbClr r="0" g="0" b="0"/>
-          </a:lnRef>
-          <a:fillRef idx="0">
-            <a:scrgbClr r="0" g="0" b="0"/>
-          </a:fillRef>
-          <a:effectRef idx="0">
-            <a:scrgbClr r="0" g="0" b="0"/>
-          </a:effectRef>
-          <a:fontRef idx="minor"/>
-        </p:style>
-        <p:txBody>
-          <a:bodyPr anchor="ctr">
-            <a:normAutofit/>
-          </a:bodyPr>
-          <a:lstStyle/>
-          <a:p>
-            <a:pPr algn="ctr"/>
-            <a:r>
-              <a:rPr lang="vi-VN" sz="1100" b="1">
-                <a:solidFill>
-                  <a:srgbClr val="92F7FF"/>
-                </a:solidFill>
-                <a:latin typeface="Archivo Light"/>
-              </a:rPr>
-              <a:t>Sơ đồ tuần tự</a:t>
-            </a:r>
-          </a:p>
-        </p:txBody>
-      </p:sp>
-      <p:pic>
-        <p:nvPicPr>
-          <p:cNvPr id="4098" name="Picture 2">
-            <a:extLst>
-              <a:ext uri="{FF2B5EF4-FFF2-40B4-BE49-F238E27FC236}">
-                <a16:creationId xmlns:a16="http://schemas.microsoft.com/office/drawing/2014/main" id="{A849432A-B6F1-51F8-D373-592602C07893}"/>
-              </a:ext>
-            </a:extLst>
-          </p:cNvPr>
-          <p:cNvPicPr>
-            <a:picLocks noChangeAspect="1" noChangeArrowheads="1"/>
-          </p:cNvPicPr>
-          <p:nvPr/>
-        </p:nvPicPr>
-        <p:blipFill>
-          <a:blip r:embed="rId3">
-            <a:extLst>
-              <a:ext uri="{28A0092B-C50C-407E-A947-70E740481C1C}">
-                <a14:useLocalDpi xmlns:a14="http://schemas.microsoft.com/office/drawing/2010/main" val="0"/>
-              </a:ext>
-            </a:extLst>
-          </a:blip>
-          <a:srcRect/>
-          <a:stretch>
-            <a:fillRect/>
-          </a:stretch>
-        </p:blipFill>
-        <p:spPr bwMode="auto">
-          <a:xfrm>
-            <a:off x="359764" y="1004734"/>
-            <a:ext cx="3094420" cy="3633687"/>
-          </a:xfrm>
-          <a:prstGeom prst="rect">
-            <a:avLst/>
-          </a:prstGeom>
-          <a:noFill/>
-          <a:ln>
-            <a:noFill/>
-          </a:ln>
-          <a:extLst>
-            <a:ext uri="{909E8E84-426E-40DD-AFC4-6F175D3DCCD1}">
-              <a14:hiddenFill xmlns:a14="http://schemas.microsoft.com/office/drawing/2010/main">
-                <a:solidFill>
-                  <a:srgbClr val="FFFFFF"/>
-                </a:solidFill>
-              </a14:hiddenFill>
-            </a:ext>
-            <a:ext uri="{91240B29-F687-4F45-9708-019B960494DF}">
-              <a14:hiddenLine xmlns:a14="http://schemas.microsoft.com/office/drawing/2010/main" w="9525">
-                <a:solidFill>
-                  <a:srgbClr val="000000"/>
-                </a:solidFill>
-                <a:miter lim="800000"/>
-                <a:headEnd/>
-                <a:tailEnd/>
-              </a14:hiddenLine>
-            </a:ext>
-          </a:extLst>
-        </p:spPr>
-      </p:pic>
-      <p:pic>
-        <p:nvPicPr>
-          <p:cNvPr id="4101" name="Picture 5">
-            <a:extLst>
-              <a:ext uri="{FF2B5EF4-FFF2-40B4-BE49-F238E27FC236}">
-                <a16:creationId xmlns:a16="http://schemas.microsoft.com/office/drawing/2014/main" id="{28E08795-69BF-D349-8A79-B569C9A3624F}"/>
-              </a:ext>
-            </a:extLst>
-          </p:cNvPr>
-          <p:cNvPicPr>
-            <a:picLocks noChangeAspect="1" noChangeArrowheads="1"/>
-          </p:cNvPicPr>
-          <p:nvPr/>
-        </p:nvPicPr>
-        <p:blipFill>
-          <a:blip r:embed="rId4">
-            <a:extLst>
-              <a:ext uri="{28A0092B-C50C-407E-A947-70E740481C1C}">
-                <a14:useLocalDpi xmlns:a14="http://schemas.microsoft.com/office/drawing/2010/main" val="0"/>
-              </a:ext>
-            </a:extLst>
-          </a:blip>
-          <a:srcRect b="4588"/>
-          <a:stretch>
-            <a:fillRect/>
-          </a:stretch>
-        </p:blipFill>
-        <p:spPr bwMode="auto">
-          <a:xfrm>
-            <a:off x="3688410" y="963156"/>
-            <a:ext cx="5095826" cy="3675265"/>
-          </a:xfrm>
-          <a:prstGeom prst="rect">
-            <a:avLst/>
-          </a:prstGeom>
-          <a:noFill/>
-          <a:ln>
-            <a:noFill/>
-          </a:ln>
-          <a:extLst>
-            <a:ext uri="{909E8E84-426E-40DD-AFC4-6F175D3DCCD1}">
-              <a14:hiddenFill xmlns:a14="http://schemas.microsoft.com/office/drawing/2010/main">
-                <a:solidFill>
-                  <a:srgbClr val="FFFFFF"/>
-                </a:solidFill>
-              </a14:hiddenFill>
-            </a:ext>
-            <a:ext uri="{91240B29-F687-4F45-9708-019B960494DF}">
-              <a14:hiddenLine xmlns:a14="http://schemas.microsoft.com/office/drawing/2010/main" w="9525">
-                <a:solidFill>
-                  <a:srgbClr val="000000"/>
-                </a:solidFill>
-                <a:miter lim="800000"/>
-                <a:headEnd/>
-                <a:tailEnd/>
-              </a14:hiddenLine>
-            </a:ext>
-          </a:extLst>
-        </p:spPr>
-      </p:pic>
-    </p:spTree>
-  </p:cSld>
-  <p:clrMapOvr>
-    <a:masterClrMapping/>
-  </p:clrMapOvr>
-  <mc:AlternateContent xmlns:mc="http://schemas.openxmlformats.org/markup-compatibility/2006" xmlns:p159="http://schemas.microsoft.com/office/powerpoint/2015/09/main">
-    <mc:Choice Requires="p159">
-      <p:transition xmlns:p14="http://schemas.microsoft.com/office/powerpoint/2010/main" spd="slow" p14:dur="2000">
-        <p159:morph option="byObject"/>
-      </p:transition>
-    </mc:Choice>
-    <mc:Fallback xmlns="">
-      <p:transition spd="slow">
-        <p:fade/>
-      </p:transition>
-    </mc:Fallback>
-  </mc:AlternateContent>
-</p:sld>
-</file>
-
-<file path=ppt/slides/slide13.xml><?xml version="1.0" encoding="utf-8"?>
 <p:sld xmlns:a="http://schemas.openxmlformats.org/drawingml/2006/main" xmlns:r="http://schemas.openxmlformats.org/officeDocument/2006/relationships" xmlns:p="http://schemas.openxmlformats.org/presentationml/2006/main">
   <p:cSld>
     <p:spTree>
@@ -19492,7 +19301,7 @@
 </p:sld>
 </file>
 
-<file path=ppt/slides/slide14.xml><?xml version="1.0" encoding="utf-8"?>
+<file path=ppt/slides/slide13.xml><?xml version="1.0" encoding="utf-8"?>
 <p:sld xmlns:a="http://schemas.openxmlformats.org/drawingml/2006/main" xmlns:r="http://schemas.openxmlformats.org/officeDocument/2006/relationships" xmlns:p="http://schemas.openxmlformats.org/presentationml/2006/main">
   <p:cSld>
     <p:spTree>
@@ -19734,10 +19543,11 @@
             </a:lvl9pPr>
           </a:lstStyle>
           <a:p>
-            <a:pPr marL="342900" defTabSz="914400">
+            <a:pPr marL="628650" indent="-285750" defTabSz="914400">
               <a:lnSpc>
                 <a:spcPct val="130000"/>
               </a:lnSpc>
+              <a:buFont typeface="Arial" panose="020B0604020202020204" pitchFamily="34" charset="0"/>
               <a:buChar char="•"/>
             </a:pPr>
             <a:r>
@@ -19747,14 +19557,15 @@
                 </a:solidFill>
                 <a:latin typeface="Archivo Light"/>
               </a:rPr>
-              <a:t>Giao diện đầy đủ cho người dùng và admin</a:t>
+              <a:t>Giao diện đầy đủ cho người dùng và quản trị viên</a:t>
             </a:r>
           </a:p>
           <a:p>
-            <a:pPr marL="342900" defTabSz="914400">
+            <a:pPr marL="628650" indent="-285750" defTabSz="914400">
               <a:lnSpc>
                 <a:spcPct val="130000"/>
               </a:lnSpc>
+              <a:buFont typeface="Arial" panose="020B0604020202020204" pitchFamily="34" charset="0"/>
               <a:buChar char="•"/>
             </a:pPr>
             <a:r>
@@ -19774,10 +19585,11 @@
             </a:endParaRPr>
           </a:p>
           <a:p>
-            <a:pPr marL="342900" defTabSz="914400">
+            <a:pPr marL="628650" indent="-285750">
               <a:lnSpc>
                 <a:spcPct val="130000"/>
               </a:lnSpc>
+              <a:buFont typeface="Arial" panose="020B0604020202020204" pitchFamily="34" charset="0"/>
               <a:buChar char="•"/>
             </a:pPr>
             <a:r>
@@ -19787,8 +19599,83 @@
                 </a:solidFill>
                 <a:latin typeface="Archivo Light"/>
               </a:rPr>
-              <a:t>Hạn chế: chưa tích hợp cổng thanh toán thực</a:t>
+              <a:t>Hạn chế: </a:t>
             </a:r>
+            <a:r>
+              <a:rPr lang="vi-VN" sz="1600">
+                <a:solidFill>
+                  <a:schemeClr val="tx2">
+                    <a:lumMod val="60000"/>
+                    <a:lumOff val="40000"/>
+                  </a:schemeClr>
+                </a:solidFill>
+                <a:latin typeface="Archivo"/>
+              </a:rPr>
+              <a:t>Đã tích hợp VNPay ở môi trường </a:t>
+            </a:r>
+            <a:r>
+              <a:rPr lang="en-US" sz="1600">
+                <a:solidFill>
+                  <a:schemeClr val="tx2">
+                    <a:lumMod val="60000"/>
+                    <a:lumOff val="40000"/>
+                  </a:schemeClr>
+                </a:solidFill>
+                <a:latin typeface="Archivo"/>
+              </a:rPr>
+              <a:t>thử nghiệm</a:t>
+            </a:r>
+            <a:r>
+              <a:rPr lang="vi-VN" sz="1600">
+                <a:solidFill>
+                  <a:schemeClr val="tx2">
+                    <a:lumMod val="60000"/>
+                    <a:lumOff val="40000"/>
+                  </a:schemeClr>
+                </a:solidFill>
+                <a:latin typeface="Archivo"/>
+              </a:rPr>
+              <a:t>, chưa triển khai với tài khoản </a:t>
+            </a:r>
+            <a:r>
+              <a:rPr lang="en-US" sz="1600">
+                <a:solidFill>
+                  <a:schemeClr val="tx2">
+                    <a:lumMod val="60000"/>
+                    <a:lumOff val="40000"/>
+                  </a:schemeClr>
+                </a:solidFill>
+                <a:latin typeface="Archivo"/>
+              </a:rPr>
+              <a:t>đối tác kinh doanh </a:t>
+            </a:r>
+            <a:r>
+              <a:rPr lang="vi-VN" sz="1600">
+                <a:solidFill>
+                  <a:schemeClr val="tx2">
+                    <a:lumMod val="60000"/>
+                    <a:lumOff val="40000"/>
+                  </a:schemeClr>
+                </a:solidFill>
+                <a:latin typeface="Archivo"/>
+              </a:rPr>
+              <a:t>(merchant) thật; chưa tích hợp thêm cổng thanh toán MoMo.</a:t>
+            </a:r>
+          </a:p>
+          <a:p>
+            <a:pPr marL="628650" indent="-285750" defTabSz="914400">
+              <a:lnSpc>
+                <a:spcPct val="130000"/>
+              </a:lnSpc>
+              <a:buFont typeface="Arial" panose="020B0604020202020204" pitchFamily="34" charset="0"/>
+              <a:buChar char="•"/>
+            </a:pPr>
+            <a:endParaRPr lang="vi-VN" sz="1600" b="0">
+              <a:solidFill>
+                <a:srgbClr val="92F7FF"/>
+              </a:solidFill>
+              <a:latin typeface="Archivo Light"/>
+            </a:endParaRPr>
           </a:p>
         </p:txBody>
       </p:sp>
@@ -19817,7 +19704,7 @@
 </p:sld>
 </file>
 
-<file path=ppt/slides/slide15.xml><?xml version="1.0" encoding="utf-8"?>
+<file path=ppt/slides/slide14.xml><?xml version="1.0" encoding="utf-8"?>
 <p:sld xmlns:a="http://schemas.openxmlformats.org/drawingml/2006/main" xmlns:r="http://schemas.openxmlformats.org/officeDocument/2006/relationships" xmlns:p="http://schemas.openxmlformats.org/presentationml/2006/main">
   <p:cSld>
     <p:spTree>
@@ -19915,7 +19802,7 @@
         </p:nvSpPr>
         <p:spPr>
           <a:xfrm>
-            <a:off x="352046" y="2023709"/>
+            <a:off x="619200" y="1490309"/>
             <a:ext cx="7615226" cy="2938034"/>
           </a:xfrm>
           <a:prstGeom prst="rect">
@@ -20038,55 +19925,289 @@
             </a:lvl9pPr>
           </a:lstStyle>
           <a:p>
-            <a:pPr marL="342900" defTabSz="914400">
-              <a:lnSpc>
-                <a:spcPct val="130000"/>
-              </a:lnSpc>
+            <a:pPr marL="285750" lvl="0" indent="-285750" algn="just">
+              <a:buFont typeface="Arial" panose="020B0604020202020204" pitchFamily="34" charset="0"/>
               <a:buChar char="•"/>
             </a:pPr>
             <a:r>
-              <a:rPr lang="vi-VN" sz="1600" b="0">
-                <a:solidFill>
-                  <a:srgbClr val="92F7FF"/>
-                </a:solidFill>
-                <a:latin typeface="Archivo Light"/>
+              <a:rPr lang="vi-VN" sz="1600">
+                <a:solidFill>
+                  <a:schemeClr val="tx2">
+                    <a:lumMod val="60000"/>
+                    <a:lumOff val="40000"/>
+                  </a:schemeClr>
+                </a:solidFill>
+                <a:latin typeface="Archivo"/>
               </a:rPr>
-              <a:t>Tích hợp thanh toán bằng ví điện tử/ngân hàng</a:t>
+              <a:t>Chuyển tích hợp VNPay từ môi trường </a:t>
+            </a:r>
+            <a:r>
+              <a:rPr lang="en-US" sz="1600">
+                <a:solidFill>
+                  <a:schemeClr val="tx2">
+                    <a:lumMod val="60000"/>
+                    <a:lumOff val="40000"/>
+                  </a:schemeClr>
+                </a:solidFill>
+                <a:latin typeface="Archivo"/>
+              </a:rPr>
+              <a:t>thử nghiệm</a:t>
+            </a:r>
+            <a:r>
+              <a:rPr lang="vi-VN" sz="1600">
+                <a:solidFill>
+                  <a:schemeClr val="tx2">
+                    <a:lumMod val="60000"/>
+                    <a:lumOff val="40000"/>
+                  </a:schemeClr>
+                </a:solidFill>
+                <a:latin typeface="Archivo"/>
+              </a:rPr>
+              <a:t> sang tài khoản </a:t>
+            </a:r>
+            <a:r>
+              <a:rPr lang="en-US" sz="1600">
+                <a:solidFill>
+                  <a:schemeClr val="tx2">
+                    <a:lumMod val="60000"/>
+                    <a:lumOff val="40000"/>
+                  </a:schemeClr>
+                </a:solidFill>
+                <a:latin typeface="Archivo"/>
+              </a:rPr>
+              <a:t>đối tác kinh doanh</a:t>
+            </a:r>
+            <a:r>
+              <a:rPr lang="vi-VN" sz="1600">
+                <a:solidFill>
+                  <a:schemeClr val="tx2">
+                    <a:lumMod val="60000"/>
+                    <a:lumOff val="40000"/>
+                  </a:schemeClr>
+                </a:solidFill>
+                <a:latin typeface="Archivo"/>
+              </a:rPr>
+              <a:t> thật; bổ sung tích hợp cổng thanh toán MoMo.</a:t>
             </a:r>
           </a:p>
           <a:p>
-            <a:pPr marL="342900" defTabSz="914400">
-              <a:lnSpc>
-                <a:spcPct val="130000"/>
-              </a:lnSpc>
+            <a:pPr marL="285750" lvl="0" indent="-285750" algn="just">
+              <a:buFont typeface="Arial" panose="020B0604020202020204" pitchFamily="34" charset="0"/>
               <a:buChar char="•"/>
             </a:pPr>
             <a:r>
-              <a:rPr lang="vi-VN" sz="1600" b="0">
-                <a:solidFill>
-                  <a:srgbClr val="92F7FF"/>
-                </a:solidFill>
-                <a:latin typeface="Archivo Light"/>
+              <a:rPr lang="vi-VN" sz="1600">
+                <a:solidFill>
+                  <a:schemeClr val="tx2">
+                    <a:lumMod val="60000"/>
+                    <a:lumOff val="40000"/>
+                  </a:schemeClr>
+                </a:solidFill>
+                <a:latin typeface="Archivo"/>
               </a:rPr>
-              <a:t>Thêm tính năng trò chuyện trực tiếp giữa người dùng</a:t>
+              <a:t>Bổ sung tính năng chat trực tiếp giữa người mua và người bán</a:t>
             </a:r>
+            <a:r>
+              <a:rPr lang="en-US" sz="1600">
+                <a:solidFill>
+                  <a:schemeClr val="tx2">
+                    <a:lumMod val="60000"/>
+                    <a:lumOff val="40000"/>
+                  </a:schemeClr>
+                </a:solidFill>
+                <a:latin typeface="Archivo"/>
+              </a:rPr>
+              <a:t>.</a:t>
+            </a:r>
+            <a:endParaRPr lang="vi-VN" sz="1600">
+              <a:solidFill>
+                <a:schemeClr val="tx2">
+                  <a:lumMod val="60000"/>
+                  <a:lumOff val="40000"/>
+                </a:schemeClr>
+              </a:solidFill>
+              <a:latin typeface="Archivo"/>
+            </a:endParaRPr>
           </a:p>
           <a:p>
-            <a:pPr marL="342900" defTabSz="914400">
-              <a:lnSpc>
-                <a:spcPct val="130000"/>
-              </a:lnSpc>
+            <a:pPr marL="285750" lvl="0" indent="-285750" algn="just">
+              <a:buFont typeface="Arial" panose="020B0604020202020204" pitchFamily="34" charset="0"/>
               <a:buChar char="•"/>
             </a:pPr>
             <a:r>
-              <a:rPr lang="vi-VN" sz="1600" b="0">
-                <a:solidFill>
-                  <a:srgbClr val="92F7FF"/>
-                </a:solidFill>
-                <a:latin typeface="Archivo Light"/>
+              <a:rPr lang="vi-VN" sz="1600">
+                <a:solidFill>
+                  <a:schemeClr val="tx2">
+                    <a:lumMod val="60000"/>
+                    <a:lumOff val="40000"/>
+                  </a:schemeClr>
+                </a:solidFill>
+                <a:latin typeface="Archivo"/>
               </a:rPr>
-              <a:t>Phát triển ứng dụng di động</a:t>
+              <a:t>Tích hợp tính năng </a:t>
             </a:r>
+            <a:r>
+              <a:rPr lang="en-US" sz="1600">
+                <a:solidFill>
+                  <a:schemeClr val="tx2">
+                    <a:lumMod val="60000"/>
+                    <a:lumOff val="40000"/>
+                  </a:schemeClr>
+                </a:solidFill>
+                <a:latin typeface="Archivo"/>
+              </a:rPr>
+              <a:t>đánh giá</a:t>
+            </a:r>
+            <a:r>
+              <a:rPr lang="vi-VN" sz="1600">
+                <a:solidFill>
+                  <a:schemeClr val="tx2">
+                    <a:lumMod val="60000"/>
+                    <a:lumOff val="40000"/>
+                  </a:schemeClr>
+                </a:solidFill>
+                <a:latin typeface="Archivo"/>
+              </a:rPr>
+              <a:t> sau mỗi giao dịch hoàn thành, </a:t>
+            </a:r>
+            <a:r>
+              <a:rPr lang="en-US" sz="1600">
+                <a:solidFill>
+                  <a:schemeClr val="tx2">
+                    <a:lumMod val="60000"/>
+                    <a:lumOff val="40000"/>
+                  </a:schemeClr>
+                </a:solidFill>
+                <a:latin typeface="Archivo"/>
+              </a:rPr>
+              <a:t>đồng thời tích hợp tính điểm tín nhiệm dựa trên các đánh giá.</a:t>
+            </a:r>
+            <a:endParaRPr lang="vi-VN" sz="1600">
+              <a:solidFill>
+                <a:schemeClr val="tx2">
+                  <a:lumMod val="60000"/>
+                  <a:lumOff val="40000"/>
+                </a:schemeClr>
+              </a:solidFill>
+              <a:latin typeface="Archivo"/>
+            </a:endParaRPr>
+          </a:p>
+          <a:p>
+            <a:pPr marL="285750" lvl="0" indent="-285750" algn="just">
+              <a:buFont typeface="Arial" panose="020B0604020202020204" pitchFamily="34" charset="0"/>
+              <a:buChar char="•"/>
+            </a:pPr>
+            <a:r>
+              <a:rPr lang="vi-VN" sz="1600">
+                <a:solidFill>
+                  <a:schemeClr val="tx2">
+                    <a:lumMod val="60000"/>
+                    <a:lumOff val="40000"/>
+                  </a:schemeClr>
+                </a:solidFill>
+                <a:latin typeface="Archivo"/>
+              </a:rPr>
+              <a:t>Tối ưu hiệu năng truy vấn cơ sở dữ liệu bằng JOIN FETCH, caching (Redis) khi mở rộng quy mô</a:t>
+            </a:r>
+            <a:r>
+              <a:rPr lang="en-US" sz="1600">
+                <a:solidFill>
+                  <a:schemeClr val="tx2">
+                    <a:lumMod val="60000"/>
+                    <a:lumOff val="40000"/>
+                  </a:schemeClr>
+                </a:solidFill>
+                <a:latin typeface="Archivo"/>
+              </a:rPr>
+              <a:t>.</a:t>
+            </a:r>
+            <a:endParaRPr lang="vi-VN" sz="1600">
+              <a:solidFill>
+                <a:schemeClr val="tx2">
+                  <a:lumMod val="60000"/>
+                  <a:lumOff val="40000"/>
+                </a:schemeClr>
+              </a:solidFill>
+              <a:latin typeface="Archivo"/>
+            </a:endParaRPr>
+          </a:p>
+          <a:p>
+            <a:pPr marL="285750" lvl="0" indent="-285750" algn="just">
+              <a:buFont typeface="Arial" panose="020B0604020202020204" pitchFamily="34" charset="0"/>
+              <a:buChar char="•"/>
+            </a:pPr>
+            <a:r>
+              <a:rPr lang="vi-VN" sz="1600">
+                <a:solidFill>
+                  <a:schemeClr val="tx2">
+                    <a:lumMod val="60000"/>
+                    <a:lumOff val="40000"/>
+                  </a:schemeClr>
+                </a:solidFill>
+                <a:latin typeface="Archivo"/>
+              </a:rPr>
+              <a:t>Thực hiện kiểm thử tải để đánh giá khả năng chịu tải khi có nhiều người dùng đặt giá đồng thời</a:t>
+            </a:r>
+            <a:r>
+              <a:rPr lang="en-US" sz="1600">
+                <a:solidFill>
+                  <a:schemeClr val="tx2">
+                    <a:lumMod val="60000"/>
+                    <a:lumOff val="40000"/>
+                  </a:schemeClr>
+                </a:solidFill>
+                <a:latin typeface="Archivo"/>
+              </a:rPr>
+              <a:t>.</a:t>
+            </a:r>
+            <a:endParaRPr lang="vi-VN" sz="1600">
+              <a:solidFill>
+                <a:schemeClr val="tx2">
+                  <a:lumMod val="60000"/>
+                  <a:lumOff val="40000"/>
+                </a:schemeClr>
+              </a:solidFill>
+              <a:latin typeface="Archivo"/>
+            </a:endParaRPr>
+          </a:p>
+          <a:p>
+            <a:pPr marL="285750" lvl="0" indent="-285750" algn="just">
+              <a:buFont typeface="Arial" panose="020B0604020202020204" pitchFamily="34" charset="0"/>
+              <a:buChar char="•"/>
+            </a:pPr>
+            <a:r>
+              <a:rPr lang="vi-VN" sz="1600">
+                <a:solidFill>
+                  <a:schemeClr val="tx2">
+                    <a:lumMod val="60000"/>
+                    <a:lumOff val="40000"/>
+                  </a:schemeClr>
+                </a:solidFill>
+                <a:latin typeface="Archivo"/>
+              </a:rPr>
+              <a:t>Phát triển ứng dụng di động (mobile app) để tăng khả năng tiếp cận người dùng</a:t>
+            </a:r>
+            <a:r>
+              <a:rPr lang="en-US" sz="1600">
+                <a:solidFill>
+                  <a:schemeClr val="tx2">
+                    <a:lumMod val="60000"/>
+                    <a:lumOff val="40000"/>
+                  </a:schemeClr>
+                </a:solidFill>
+                <a:latin typeface="Archivo"/>
+              </a:rPr>
+              <a:t>.</a:t>
+            </a:r>
+            <a:endParaRPr lang="vi-VN" sz="1600">
+              <a:solidFill>
+                <a:schemeClr val="tx2">
+                  <a:lumMod val="60000"/>
+                  <a:lumOff val="40000"/>
+                </a:schemeClr>
+              </a:solidFill>
+              <a:latin typeface="Archivo"/>
+            </a:endParaRPr>
           </a:p>
         </p:txBody>
       </p:sp>
@@ -20110,7 +20231,7 @@
 </p:sld>
 </file>
 
-<file path=ppt/slides/slide16.xml><?xml version="1.0" encoding="utf-8"?>
+<file path=ppt/slides/slide15.xml><?xml version="1.0" encoding="utf-8"?>
 <p:sld xmlns:a="http://schemas.openxmlformats.org/drawingml/2006/main" xmlns:r="http://schemas.openxmlformats.org/officeDocument/2006/relationships" xmlns:p="http://schemas.openxmlformats.org/presentationml/2006/main">
   <p:cSld>
     <p:spTree>
@@ -20349,7 +20470,7 @@
                 </a:solidFill>
                 <a:latin typeface="Archivo Light"/>
               </a:rPr>
-              <a:t>GVHD: Ths. Ngô Thanh Huy</a:t>
+              <a:t>GVHD: ThS. Ngô Thanh Huy</a:t>
             </a:r>
           </a:p>
           <a:p>
@@ -20701,10 +20822,11 @@
             </a:r>
           </a:p>
           <a:p>
-            <a:pPr marL="342900" algn="just" defTabSz="914400">
+            <a:pPr marL="628650" indent="-285750" algn="just" defTabSz="914400">
               <a:lnSpc>
                 <a:spcPct val="130000"/>
               </a:lnSpc>
+              <a:buFont typeface="Arial" panose="020B0604020202020204" pitchFamily="34" charset="0"/>
               <a:buChar char="•"/>
             </a:pPr>
             <a:r>
@@ -20718,10 +20840,11 @@
             </a:r>
           </a:p>
           <a:p>
-            <a:pPr marL="342900" algn="just" defTabSz="914400">
+            <a:pPr marL="628650" indent="-285750" algn="just" defTabSz="914400">
               <a:lnSpc>
                 <a:spcPct val="130000"/>
               </a:lnSpc>
+              <a:buFont typeface="Arial" panose="020B0604020202020204" pitchFamily="34" charset="0"/>
               <a:buChar char="•"/>
             </a:pPr>
             <a:r>
@@ -20735,10 +20858,11 @@
             </a:r>
           </a:p>
           <a:p>
-            <a:pPr marL="342900" algn="just" defTabSz="914400">
+            <a:pPr marL="628650" indent="-285750" algn="just" defTabSz="914400">
               <a:lnSpc>
                 <a:spcPct val="130000"/>
               </a:lnSpc>
+              <a:buFont typeface="Arial" panose="020B0604020202020204" pitchFamily="34" charset="0"/>
               <a:buChar char="•"/>
             </a:pPr>
             <a:r>
@@ -20750,6 +20874,30 @@
               </a:rPr>
               <a:t>Quản lý đơn hàng, thông báo, kiểm duyệt</a:t>
             </a:r>
+          </a:p>
+          <a:p>
+            <a:pPr marL="628650" indent="-285750" algn="just" defTabSz="914400">
+              <a:lnSpc>
+                <a:spcPct val="130000"/>
+              </a:lnSpc>
+              <a:buFont typeface="Arial" panose="020B0604020202020204" pitchFamily="34" charset="0"/>
+              <a:buChar char="•"/>
+            </a:pPr>
+            <a:r>
+              <a:rPr lang="vi-VN" sz="1400">
+                <a:solidFill>
+                  <a:srgbClr val="92F7FF"/>
+                </a:solidFill>
+                <a:latin typeface="Archivo Light"/>
+              </a:rPr>
+              <a:t>Nạp tiền vào ví và rút tiền về tài khoản ngân hàng</a:t>
+            </a:r>
+            <a:endParaRPr lang="vi-VN" sz="1400" b="0">
+              <a:solidFill>
+                <a:srgbClr val="92F7FF"/>
+              </a:solidFill>
+              <a:latin typeface="Archivo Light"/>
+            </a:endParaRPr>
           </a:p>
         </p:txBody>
       </p:sp>
@@ -21602,10 +21750,11 @@
             </a:lvl9pPr>
           </a:lstStyle>
           <a:p>
-            <a:pPr marL="342900" defTabSz="914400">
+            <a:pPr marL="628650" indent="-285750" defTabSz="914400">
               <a:lnSpc>
                 <a:spcPct val="130000"/>
               </a:lnSpc>
+              <a:buFont typeface="Arial" panose="020B0604020202020204" pitchFamily="34" charset="0"/>
               <a:buChar char="•"/>
             </a:pPr>
             <a:r>
@@ -21619,10 +21768,11 @@
             </a:r>
           </a:p>
           <a:p>
-            <a:pPr marL="342900" defTabSz="914400">
+            <a:pPr marL="628650" indent="-285750" defTabSz="914400">
               <a:lnSpc>
                 <a:spcPct val="130000"/>
               </a:lnSpc>
+              <a:buFont typeface="Arial" panose="020B0604020202020204" pitchFamily="34" charset="0"/>
               <a:buChar char="•"/>
             </a:pPr>
             <a:r>
@@ -21636,10 +21786,11 @@
             </a:r>
           </a:p>
           <a:p>
-            <a:pPr marL="342900" defTabSz="914400">
+            <a:pPr marL="628650" indent="-285750" defTabSz="914400">
               <a:lnSpc>
                 <a:spcPct val="130000"/>
               </a:lnSpc>
+              <a:buFont typeface="Arial" panose="020B0604020202020204" pitchFamily="34" charset="0"/>
               <a:buChar char="•"/>
             </a:pPr>
             <a:r>
@@ -21653,10 +21804,11 @@
             </a:r>
           </a:p>
           <a:p>
-            <a:pPr marL="342900" defTabSz="914400">
+            <a:pPr marL="628650" indent="-285750" defTabSz="914400">
               <a:lnSpc>
                 <a:spcPct val="130000"/>
               </a:lnSpc>
+              <a:buFont typeface="Arial" panose="020B0604020202020204" pitchFamily="34" charset="0"/>
               <a:buChar char="•"/>
             </a:pPr>
             <a:r>
@@ -21670,10 +21822,11 @@
             </a:r>
           </a:p>
           <a:p>
-            <a:pPr marL="342900" defTabSz="914400">
+            <a:pPr marL="628650" indent="-285750" defTabSz="914400">
               <a:lnSpc>
                 <a:spcPct val="130000"/>
               </a:lnSpc>
+              <a:buFont typeface="Arial" panose="020B0604020202020204" pitchFamily="34" charset="0"/>
               <a:buChar char="•"/>
             </a:pPr>
             <a:r>
@@ -21831,7 +21984,7 @@
         </p:style>
         <p:txBody>
           <a:bodyPr anchor="t">
-            <a:normAutofit/>
+            <a:normAutofit lnSpcReduction="10000"/>
           </a:bodyPr>
           <a:lstStyle>
             <a:defPPr>
@@ -21951,11 +22104,11 @@
             </a:endParaRPr>
           </a:p>
           <a:p>
-            <a:pPr marL="342900">
+            <a:pPr marL="628650" indent="-285750">
               <a:lnSpc>
                 <a:spcPct val="130000"/>
               </a:lnSpc>
-              <a:buFontTx/>
+              <a:buFont typeface="Arial" panose="020B0604020202020204" pitchFamily="34" charset="0"/>
               <a:buChar char="•"/>
             </a:pPr>
             <a:r>
@@ -21969,11 +22122,11 @@
             </a:r>
           </a:p>
           <a:p>
-            <a:pPr marL="342900">
+            <a:pPr marL="628650" indent="-285750">
               <a:lnSpc>
                 <a:spcPct val="130000"/>
               </a:lnSpc>
-              <a:buFontTx/>
+              <a:buFont typeface="Arial" panose="020B0604020202020204" pitchFamily="34" charset="0"/>
               <a:buChar char="•"/>
             </a:pPr>
             <a:r>
@@ -21993,10 +22146,11 @@
             </a:endParaRPr>
           </a:p>
           <a:p>
-            <a:pPr marL="342900" defTabSz="914400">
+            <a:pPr marL="628650" indent="-285750" defTabSz="914400">
               <a:lnSpc>
                 <a:spcPct val="130000"/>
               </a:lnSpc>
+              <a:buFont typeface="Arial" panose="020B0604020202020204" pitchFamily="34" charset="0"/>
               <a:buChar char="•"/>
             </a:pPr>
             <a:r>
@@ -22010,10 +22164,11 @@
             </a:r>
           </a:p>
           <a:p>
-            <a:pPr marL="342900" defTabSz="914400">
+            <a:pPr marL="628650" indent="-285750" defTabSz="914400">
               <a:lnSpc>
                 <a:spcPct val="130000"/>
               </a:lnSpc>
+              <a:buFont typeface="Arial" panose="020B0604020202020204" pitchFamily="34" charset="0"/>
               <a:buChar char="•"/>
             </a:pPr>
             <a:r>
@@ -22027,10 +22182,11 @@
             </a:r>
           </a:p>
           <a:p>
-            <a:pPr marL="342900" defTabSz="914400">
+            <a:pPr marL="628650" indent="-285750" defTabSz="914400">
               <a:lnSpc>
                 <a:spcPct val="130000"/>
               </a:lnSpc>
+              <a:buFont typeface="Arial" panose="020B0604020202020204" pitchFamily="34" charset="0"/>
               <a:buChar char="•"/>
             </a:pPr>
             <a:r>
@@ -22073,10 +22229,11 @@
             </a:r>
           </a:p>
           <a:p>
-            <a:pPr marL="342900" defTabSz="914400">
+            <a:pPr marL="628650" indent="-285750">
               <a:lnSpc>
                 <a:spcPct val="130000"/>
               </a:lnSpc>
+              <a:buFont typeface="Arial" panose="020B0604020202020204" pitchFamily="34" charset="0"/>
               <a:buChar char="•"/>
             </a:pPr>
             <a:r>
@@ -22086,20 +22243,27 @@
                 </a:solidFill>
                 <a:latin typeface="Archivo Light"/>
               </a:rPr>
-              <a:t>Triển khai web, mô phỏng thanh toán</a:t>
+              <a:t>Triển khai web, </a:t>
             </a:r>
-            <a:endParaRPr lang="vi-VN" sz="1600" b="0">
-              <a:solidFill>
-                <a:srgbClr val="92F7FF"/>
-              </a:solidFill>
-              <a:latin typeface="Archivo Light"/>
-            </a:endParaRPr>
+            <a:r>
+              <a:rPr lang="vi-VN" sz="1600">
+                <a:solidFill>
+                  <a:schemeClr val="tx2">
+                    <a:lumMod val="60000"/>
+                    <a:lumOff val="40000"/>
+                  </a:schemeClr>
+                </a:solidFill>
+                <a:latin typeface="Archivo"/>
+              </a:rPr>
+              <a:t>nạp tiền và thanh toán đơn hàng được tích hợp qua cổng thanh toán VNPay ở môi trường thử nghiệm </a:t>
+            </a:r>
           </a:p>
           <a:p>
-            <a:pPr marL="342900" defTabSz="914400">
+            <a:pPr marL="628650" indent="-285750">
               <a:lnSpc>
                 <a:spcPct val="130000"/>
               </a:lnSpc>
+              <a:buFont typeface="Arial" panose="020B0604020202020204" pitchFamily="34" charset="0"/>
               <a:buChar char="•"/>
             </a:pPr>
             <a:r>
@@ -22109,7 +22273,7 @@
                 </a:solidFill>
                 <a:latin typeface="Archivo Light"/>
               </a:rPr>
-              <a:t>Không bao gồm: cổng thanh toán thực, ứng dụng di động</a:t>
+              <a:t>Không bao gồm: ứng dụng di động</a:t>
             </a:r>
           </a:p>
           <a:p>
@@ -22650,10 +22814,11 @@
             </a:lvl9pPr>
           </a:lstStyle>
           <a:p>
-            <a:pPr marL="342900" defTabSz="914400">
+            <a:pPr marL="628650" indent="-285750" defTabSz="914400">
               <a:lnSpc>
                 <a:spcPct val="130000"/>
               </a:lnSpc>
+              <a:buFont typeface="Arial" panose="020B0604020202020204" pitchFamily="34" charset="0"/>
               <a:buChar char="•"/>
             </a:pPr>
             <a:r>
@@ -22667,10 +22832,11 @@
             </a:r>
           </a:p>
           <a:p>
-            <a:pPr marL="342900" defTabSz="914400">
+            <a:pPr marL="628650" indent="-285750" defTabSz="914400">
               <a:lnSpc>
                 <a:spcPct val="130000"/>
               </a:lnSpc>
+              <a:buFont typeface="Arial" panose="020B0604020202020204" pitchFamily="34" charset="0"/>
               <a:buChar char="•"/>
             </a:pPr>
             <a:r>
@@ -22684,10 +22850,11 @@
             </a:r>
           </a:p>
           <a:p>
-            <a:pPr marL="342900" defTabSz="914400">
+            <a:pPr marL="628650" indent="-285750" defTabSz="914400">
               <a:lnSpc>
                 <a:spcPct val="130000"/>
               </a:lnSpc>
+              <a:buFont typeface="Arial" panose="020B0604020202020204" pitchFamily="34" charset="0"/>
               <a:buChar char="•"/>
             </a:pPr>
             <a:r>
@@ -22701,10 +22868,11 @@
             </a:r>
           </a:p>
           <a:p>
-            <a:pPr marL="342900" defTabSz="914400">
+            <a:pPr marL="628650" indent="-285750" defTabSz="914400">
               <a:lnSpc>
                 <a:spcPct val="130000"/>
               </a:lnSpc>
+              <a:buFont typeface="Arial" panose="020B0604020202020204" pitchFamily="34" charset="0"/>
               <a:buChar char="•"/>
             </a:pPr>
             <a:r>
@@ -22724,10 +22892,11 @@
             </a:endParaRPr>
           </a:p>
           <a:p>
-            <a:pPr marL="342900" defTabSz="914400">
+            <a:pPr marL="628650" indent="-285750" defTabSz="914400">
               <a:lnSpc>
                 <a:spcPct val="130000"/>
               </a:lnSpc>
+              <a:buFont typeface="Arial" panose="020B0604020202020204" pitchFamily="34" charset="0"/>
               <a:buChar char="•"/>
             </a:pPr>
             <a:r>
@@ -22741,10 +22910,11 @@
             </a:r>
           </a:p>
           <a:p>
-            <a:pPr marL="342900" defTabSz="914400">
+            <a:pPr marL="628650" indent="-285750" defTabSz="914400">
               <a:lnSpc>
                 <a:spcPct val="130000"/>
               </a:lnSpc>
+              <a:buFont typeface="Arial" panose="020B0604020202020204" pitchFamily="34" charset="0"/>
               <a:buChar char="•"/>
             </a:pPr>
             <a:r>
@@ -22754,14 +22924,15 @@
                 </a:solidFill>
                 <a:latin typeface="Archivo Light"/>
               </a:rPr>
-              <a:t>Scheduler tự động cập nhật trạng thái mỗi 30 giây</a:t>
+              <a:t>Scheduler tự động cập nhật trạng thái </a:t>
             </a:r>
           </a:p>
           <a:p>
-            <a:pPr marL="342900" defTabSz="914400">
+            <a:pPr marL="628650" indent="-285750" defTabSz="914400">
               <a:lnSpc>
                 <a:spcPct val="130000"/>
               </a:lnSpc>
+              <a:buFont typeface="Arial" panose="020B0604020202020204" pitchFamily="34" charset="0"/>
               <a:buChar char="•"/>
             </a:pPr>
             <a:r>
@@ -22992,70 +23163,10 @@
       </p:sp>
       <p:pic>
         <p:nvPicPr>
-          <p:cNvPr id="1027" name="Picture 3">
+          <p:cNvPr id="4" name="Picture 3">
             <a:extLst>
               <a:ext uri="{FF2B5EF4-FFF2-40B4-BE49-F238E27FC236}">
-                <a16:creationId xmlns:a16="http://schemas.microsoft.com/office/drawing/2014/main" id="{6A27FB7A-F6CA-A571-AC72-6D677BA47C76}"/>
-              </a:ext>
-            </a:extLst>
-          </p:cNvPr>
-          <p:cNvPicPr>
-            <a:picLocks noChangeAspect="1" noChangeArrowheads="1"/>
-          </p:cNvPicPr>
-          <p:nvPr/>
-        </p:nvPicPr>
-        <p:blipFill>
-          <a:blip r:embed="rId2">
-            <a:extLst>
-              <a:ext uri="{28A0092B-C50C-407E-A947-70E740481C1C}">
-                <a14:useLocalDpi xmlns:a14="http://schemas.microsoft.com/office/drawing/2010/main" val="0"/>
-              </a:ext>
-            </a:extLst>
-          </a:blip>
-          <a:srcRect/>
-          <a:stretch>
-            <a:fillRect/>
-          </a:stretch>
-        </p:blipFill>
-        <p:spPr bwMode="auto">
-          <a:xfrm>
-            <a:off x="5592506" y="949998"/>
-            <a:ext cx="2591579" cy="3730001"/>
-          </a:xfrm>
-          <a:prstGeom prst="rect">
-            <a:avLst/>
-          </a:prstGeom>
-          <a:noFill/>
-          <a:ln>
-            <a:noFill/>
-          </a:ln>
-          <a:extLst>
-            <a:ext uri="{909E8E84-426E-40DD-AFC4-6F175D3DCCD1}">
-              <a14:hiddenFill xmlns:a14="http://schemas.microsoft.com/office/drawing/2010/main">
-                <a:solidFill>
-                  <a:srgbClr val="FFFFFF"/>
-                </a:solidFill>
-              </a14:hiddenFill>
-            </a:ext>
-            <a:ext uri="{91240B29-F687-4F45-9708-019B960494DF}">
-              <a14:hiddenLine xmlns:a14="http://schemas.microsoft.com/office/drawing/2010/main" w="9525">
-                <a:solidFill>
-                  <a:srgbClr val="000000"/>
-                </a:solidFill>
-                <a:miter lim="800000"/>
-                <a:headEnd/>
-                <a:tailEnd/>
-              </a14:hiddenLine>
-            </a:ext>
-          </a:extLst>
-        </p:spPr>
-      </p:pic>
-      <p:pic>
-        <p:nvPicPr>
-          <p:cNvPr id="3" name="Picture 2">
-            <a:extLst>
-              <a:ext uri="{FF2B5EF4-FFF2-40B4-BE49-F238E27FC236}">
-                <a16:creationId xmlns:a16="http://schemas.microsoft.com/office/drawing/2014/main" id="{A801AF30-A831-DB6B-05AB-6EA4DCE7A39E}"/>
+                <a16:creationId xmlns:a16="http://schemas.microsoft.com/office/drawing/2014/main" id="{34C7D474-1575-E59C-3783-928E5294F90B}"/>
               </a:ext>
             </a:extLst>
           </p:cNvPr>
@@ -23065,16 +23176,57 @@
           <p:nvPr/>
         </p:nvPicPr>
         <p:blipFill>
-          <a:blip r:embed="rId3"/>
-          <a:srcRect l="6867" t="2477"/>
+          <a:blip r:embed="rId2" cstate="print">
+            <a:extLst>
+              <a:ext uri="{28A0092B-C50C-407E-A947-70E740481C1C}">
+                <a14:useLocalDpi xmlns:a14="http://schemas.microsoft.com/office/drawing/2010/main" val="0"/>
+              </a:ext>
+            </a:extLst>
+          </a:blip>
           <a:stretch>
             <a:fillRect/>
           </a:stretch>
         </p:blipFill>
         <p:spPr>
           <a:xfrm>
-            <a:off x="872200" y="949998"/>
-            <a:ext cx="3682443" cy="3730001"/>
+            <a:off x="824823" y="880000"/>
+            <a:ext cx="3832377" cy="3819088"/>
+          </a:xfrm>
+          <a:prstGeom prst="rect">
+            <a:avLst/>
+          </a:prstGeom>
+        </p:spPr>
+      </p:pic>
+      <p:pic>
+        <p:nvPicPr>
+          <p:cNvPr id="6" name="Picture 5">
+            <a:extLst>
+              <a:ext uri="{FF2B5EF4-FFF2-40B4-BE49-F238E27FC236}">
+                <a16:creationId xmlns:a16="http://schemas.microsoft.com/office/drawing/2014/main" id="{780E7D85-5818-B144-59EF-AE643578E81A}"/>
+              </a:ext>
+            </a:extLst>
+          </p:cNvPr>
+          <p:cNvPicPr>
+            <a:picLocks noChangeAspect="1"/>
+          </p:cNvPicPr>
+          <p:nvPr/>
+        </p:nvPicPr>
+        <p:blipFill>
+          <a:blip r:embed="rId3">
+            <a:extLst>
+              <a:ext uri="{28A0092B-C50C-407E-A947-70E740481C1C}">
+                <a14:useLocalDpi xmlns:a14="http://schemas.microsoft.com/office/drawing/2010/main" val="0"/>
+              </a:ext>
+            </a:extLst>
+          </a:blip>
+          <a:stretch>
+            <a:fillRect/>
+          </a:stretch>
+        </p:blipFill>
+        <p:spPr>
+          <a:xfrm>
+            <a:off x="5461819" y="881462"/>
+            <a:ext cx="2801602" cy="3779108"/>
           </a:xfrm>
           <a:prstGeom prst="rect">
             <a:avLst/>

</xml_diff>